<commit_message>
Afegeix imatges al temari i a les diapositives dels subtemes 1 i 2 (AA1/AA2)
Segueix el mateix pilot aplicat abans a AA3: incorpora imatges tant al
document de teoria (.md i .docx) com a la presentacio (.pptx) de cada
subtema, sense modificar el contingut textual ja existent.

AA1 (Seguretat passiva): triangle del foc (diagrama propi), extintor,
tanca perimetral i una escena de pellicula sobre deteccio d'intrusos
(fotografies facilitades pel professorat).

AA2 (SAI): SAI APC part davantera i posterior (fotografies facilitades
pel professorat), i dos diagrames propis (tipus de SAI/temps de
transferencia, i W vs VA). Tambe s'afegeix una nota sobre llamps i
sobretensions facilitada pel professorat.
</commit_message>
<xml_diff>
--- a/RA1 - Seguretat passiva/AA1 - Seguretat passiva/RA1_AA1_Seguretat_Passiva.pptx
+++ b/RA1 - Seguretat passiva/AA1 - Seguretat passiva/RA1_AA1_Seguretat_Passiva.pptx
@@ -20,11 +20,15 @@
     <p:sldId id="268" r:id="rId14"/>
     <p:sldId id="269" r:id="rId15"/>
     <p:sldId id="270" r:id="rId16"/>
+    <p:sldId id="279" r:id="rId30"/>
     <p:sldId id="271" r:id="rId17"/>
+    <p:sldId id="280" r:id="rId31"/>
     <p:sldId id="272" r:id="rId18"/>
     <p:sldId id="273" r:id="rId19"/>
+    <p:sldId id="281" r:id="rId32"/>
     <p:sldId id="274" r:id="rId20"/>
     <p:sldId id="275" r:id="rId21"/>
+    <p:sldId id="282" r:id="rId33"/>
     <p:sldId id="276" r:id="rId22"/>
     <p:sldId id="277" r:id="rId23"/>
     <p:sldId id="278" r:id="rId24"/>
@@ -2852,6 +2856,10 @@
           </a:solidFill>
           <a:ln/>
         </p:spPr>
+        <p:txBody>
+          <a:bodyPr/>
+          <a:p/>
+        </p:txBody>
       </p:sp>
       <p:sp>
         <p:nvSpPr>
@@ -2874,6 +2882,10 @@
           </a:solidFill>
           <a:ln/>
         </p:spPr>
+        <p:txBody>
+          <a:bodyPr/>
+          <a:p/>
+        </p:txBody>
       </p:sp>
       <p:sp>
         <p:nvSpPr>
@@ -2894,6 +2906,10 @@
           </a:solidFill>
           <a:ln/>
         </p:spPr>
+        <p:txBody>
+          <a:bodyPr/>
+          <a:p/>
+        </p:txBody>
       </p:sp>
       <p:pic>
         <p:nvPicPr>
@@ -3058,6 +3074,10 @@
             <a:prstDash val="solid"/>
           </a:ln>
         </p:spPr>
+        <p:txBody>
+          <a:bodyPr/>
+          <a:p/>
+        </p:txBody>
       </p:sp>
       <p:sp>
         <p:nvSpPr>
@@ -3314,6 +3334,10 @@
             </a:outerShdw>
           </a:effectLst>
         </p:spPr>
+        <p:txBody>
+          <a:bodyPr/>
+          <a:p/>
+        </p:txBody>
       </p:sp>
       <p:sp>
         <p:nvSpPr>
@@ -3334,6 +3358,10 @@
           </a:solidFill>
           <a:ln/>
         </p:spPr>
+        <p:txBody>
+          <a:bodyPr/>
+          <a:p/>
+        </p:txBody>
       </p:sp>
       <p:pic>
         <p:nvPicPr>
@@ -3465,6 +3493,10 @@
             </a:outerShdw>
           </a:effectLst>
         </p:spPr>
+        <p:txBody>
+          <a:bodyPr/>
+          <a:p/>
+        </p:txBody>
       </p:sp>
       <p:sp>
         <p:nvSpPr>
@@ -3485,6 +3517,10 @@
           </a:solidFill>
           <a:ln/>
         </p:spPr>
+        <p:txBody>
+          <a:bodyPr/>
+          <a:p/>
+        </p:txBody>
       </p:sp>
       <p:pic>
         <p:nvPicPr>
@@ -3616,6 +3652,10 @@
             </a:outerShdw>
           </a:effectLst>
         </p:spPr>
+        <p:txBody>
+          <a:bodyPr/>
+          <a:p/>
+        </p:txBody>
       </p:sp>
       <p:sp>
         <p:nvSpPr>
@@ -3636,6 +3676,10 @@
           </a:solidFill>
           <a:ln/>
         </p:spPr>
+        <p:txBody>
+          <a:bodyPr/>
+          <a:p/>
+        </p:txBody>
       </p:sp>
       <p:pic>
         <p:nvPicPr>
@@ -3767,6 +3811,10 @@
             </a:outerShdw>
           </a:effectLst>
         </p:spPr>
+        <p:txBody>
+          <a:bodyPr/>
+          <a:p/>
+        </p:txBody>
       </p:sp>
       <p:sp>
         <p:nvSpPr>
@@ -3787,6 +3835,10 @@
           </a:solidFill>
           <a:ln/>
         </p:spPr>
+        <p:txBody>
+          <a:bodyPr/>
+          <a:p/>
+        </p:txBody>
       </p:sp>
       <p:pic>
         <p:nvPicPr>
@@ -3980,6 +4032,10 @@
           </a:solidFill>
           <a:ln/>
         </p:spPr>
+        <p:txBody>
+          <a:bodyPr/>
+          <a:p/>
+        </p:txBody>
       </p:sp>
       <p:sp>
         <p:nvSpPr>
@@ -4085,6 +4141,10 @@
             <a:prstDash val="solid"/>
           </a:ln>
         </p:spPr>
+        <p:txBody>
+          <a:bodyPr/>
+          <a:p/>
+        </p:txBody>
       </p:sp>
       <p:sp>
         <p:nvSpPr>
@@ -4105,6 +4165,10 @@
           </a:solidFill>
           <a:ln/>
         </p:spPr>
+        <p:txBody>
+          <a:bodyPr/>
+          <a:p/>
+        </p:txBody>
       </p:sp>
       <p:pic>
         <p:nvPicPr>
@@ -4229,6 +4293,10 @@
           </a:solidFill>
           <a:ln/>
         </p:spPr>
+        <p:txBody>
+          <a:bodyPr/>
+          <a:p/>
+        </p:txBody>
       </p:sp>
       <p:sp>
         <p:nvSpPr>
@@ -4249,6 +4317,10 @@
           </a:solidFill>
           <a:ln/>
         </p:spPr>
+        <p:txBody>
+          <a:bodyPr/>
+          <a:p/>
+        </p:txBody>
       </p:sp>
       <p:pic>
         <p:nvPicPr>
@@ -4607,6 +4679,10 @@
           </a:solidFill>
           <a:ln/>
         </p:spPr>
+        <p:txBody>
+          <a:bodyPr/>
+          <a:p/>
+        </p:txBody>
       </p:sp>
       <p:sp>
         <p:nvSpPr>
@@ -4707,6 +4783,10 @@
           </a:solidFill>
           <a:ln/>
         </p:spPr>
+        <p:txBody>
+          <a:bodyPr/>
+          <a:p/>
+        </p:txBody>
       </p:sp>
       <p:sp>
         <p:nvSpPr>
@@ -4805,6 +4885,10 @@
           </a:solidFill>
           <a:ln/>
         </p:spPr>
+        <p:txBody>
+          <a:bodyPr/>
+          <a:p/>
+        </p:txBody>
       </p:sp>
       <p:pic>
         <p:nvPicPr>
@@ -5046,6 +5130,10 @@
             </a:outerShdw>
           </a:effectLst>
         </p:spPr>
+        <p:txBody>
+          <a:bodyPr/>
+          <a:p/>
+        </p:txBody>
       </p:sp>
       <p:sp>
         <p:nvSpPr>
@@ -5066,6 +5154,10 @@
           </a:solidFill>
           <a:ln/>
         </p:spPr>
+        <p:txBody>
+          <a:bodyPr/>
+          <a:p/>
+        </p:txBody>
       </p:sp>
       <p:pic>
         <p:nvPicPr>
@@ -5236,6 +5328,10 @@
             </a:outerShdw>
           </a:effectLst>
         </p:spPr>
+        <p:txBody>
+          <a:bodyPr/>
+          <a:p/>
+        </p:txBody>
       </p:sp>
       <p:sp>
         <p:nvSpPr>
@@ -5256,6 +5352,10 @@
           </a:solidFill>
           <a:ln/>
         </p:spPr>
+        <p:txBody>
+          <a:bodyPr/>
+          <a:p/>
+        </p:txBody>
       </p:sp>
       <p:pic>
         <p:nvPicPr>
@@ -5591,6 +5691,10 @@
           </a:solidFill>
           <a:ln/>
         </p:spPr>
+        <p:txBody>
+          <a:bodyPr/>
+          <a:p/>
+        </p:txBody>
       </p:sp>
       <p:pic>
         <p:nvPicPr>
@@ -5706,6 +5810,10 @@
             </a:outerShdw>
           </a:effectLst>
         </p:spPr>
+        <p:txBody>
+          <a:bodyPr/>
+          <a:p/>
+        </p:txBody>
       </p:sp>
       <p:sp>
         <p:nvSpPr>
@@ -5978,6 +6086,10 @@
           </a:solidFill>
           <a:ln/>
         </p:spPr>
+        <p:txBody>
+          <a:bodyPr/>
+          <a:p/>
+        </p:txBody>
       </p:sp>
       <p:pic>
         <p:nvPicPr>
@@ -6061,6 +6173,10 @@
           </a:solidFill>
           <a:ln/>
         </p:spPr>
+        <p:txBody>
+          <a:bodyPr/>
+          <a:p/>
+        </p:txBody>
       </p:sp>
       <p:pic>
         <p:nvPicPr>
@@ -6144,6 +6260,10 @@
           </a:solidFill>
           <a:ln/>
         </p:spPr>
+        <p:txBody>
+          <a:bodyPr/>
+          <a:p/>
+        </p:txBody>
       </p:sp>
       <p:pic>
         <p:nvPicPr>
@@ -6234,6 +6354,10 @@
             <a:prstDash val="solid"/>
           </a:ln>
         </p:spPr>
+        <p:txBody>
+          <a:bodyPr/>
+          <a:p/>
+        </p:txBody>
       </p:sp>
       <p:sp>
         <p:nvSpPr>
@@ -6536,6 +6660,10 @@
             </a:outerShdw>
           </a:effectLst>
         </p:spPr>
+        <p:txBody>
+          <a:bodyPr/>
+          <a:p/>
+        </p:txBody>
       </p:sp>
       <p:sp>
         <p:nvSpPr>
@@ -6556,6 +6684,10 @@
           </a:solidFill>
           <a:ln/>
         </p:spPr>
+        <p:txBody>
+          <a:bodyPr/>
+          <a:p/>
+        </p:txBody>
       </p:sp>
       <p:pic>
         <p:nvPicPr>
@@ -6687,6 +6819,10 @@
             </a:outerShdw>
           </a:effectLst>
         </p:spPr>
+        <p:txBody>
+          <a:bodyPr/>
+          <a:p/>
+        </p:txBody>
       </p:sp>
       <p:sp>
         <p:nvSpPr>
@@ -6707,6 +6843,10 @@
           </a:solidFill>
           <a:ln/>
         </p:spPr>
+        <p:txBody>
+          <a:bodyPr/>
+          <a:p/>
+        </p:txBody>
       </p:sp>
       <p:pic>
         <p:nvPicPr>
@@ -8284,7 +8424,7 @@
                 <a:ea typeface="Calibri" pitchFamily="34" charset="-122"/>
                 <a:cs typeface="Calibri" pitchFamily="34" charset="-120"/>
               </a:rPr>
-              <a:t>16</a:t>
+              <a:t>17</a:t>
             </a:r>
             <a:endParaRPr lang="en-US" sz="1000" dirty="0"/>
           </a:p>
@@ -8421,6 +8561,10 @@
           </a:solidFill>
           <a:ln/>
         </p:spPr>
+        <p:txBody>
+          <a:bodyPr/>
+          <a:p/>
+        </p:txBody>
       </p:sp>
       <p:sp>
         <p:nvSpPr>
@@ -8455,7 +8599,7 @@
                 <a:ea typeface="Cambria" pitchFamily="34" charset="-122"/>
                 <a:cs typeface="Cambria" pitchFamily="34" charset="-120"/>
               </a:rPr>
-              <a:t>01</a:t>
+              <a:t>19</a:t>
             </a:r>
             <a:endParaRPr lang="en-US" sz="2000" dirty="0"/>
           </a:p>
@@ -8480,6 +8624,10 @@
           </a:solidFill>
           <a:ln/>
         </p:spPr>
+        <p:txBody>
+          <a:bodyPr/>
+          <a:p/>
+        </p:txBody>
       </p:sp>
       <p:pic>
         <p:nvPicPr>
@@ -8604,6 +8752,10 @@
           </a:solidFill>
           <a:ln/>
         </p:spPr>
+        <p:txBody>
+          <a:bodyPr/>
+          <a:p/>
+        </p:txBody>
       </p:sp>
       <p:sp>
         <p:nvSpPr>
@@ -8638,7 +8790,7 @@
                 <a:ea typeface="Cambria" pitchFamily="34" charset="-122"/>
                 <a:cs typeface="Cambria" pitchFamily="34" charset="-120"/>
               </a:rPr>
-              <a:t>02</a:t>
+              <a:t>19</a:t>
             </a:r>
             <a:endParaRPr lang="en-US" sz="2000" dirty="0"/>
           </a:p>
@@ -8663,6 +8815,10 @@
           </a:solidFill>
           <a:ln/>
         </p:spPr>
+        <p:txBody>
+          <a:bodyPr/>
+          <a:p/>
+        </p:txBody>
       </p:sp>
       <p:pic>
         <p:nvPicPr>
@@ -8787,6 +8943,10 @@
           </a:solidFill>
           <a:ln/>
         </p:spPr>
+        <p:txBody>
+          <a:bodyPr/>
+          <a:p/>
+        </p:txBody>
       </p:sp>
       <p:sp>
         <p:nvSpPr>
@@ -8821,7 +8981,7 @@
                 <a:ea typeface="Cambria" pitchFamily="34" charset="-122"/>
                 <a:cs typeface="Cambria" pitchFamily="34" charset="-120"/>
               </a:rPr>
-              <a:t>03</a:t>
+              <a:t>19</a:t>
             </a:r>
             <a:endParaRPr lang="en-US" sz="2000" dirty="0"/>
           </a:p>
@@ -8846,6 +9006,10 @@
           </a:solidFill>
           <a:ln/>
         </p:spPr>
+        <p:txBody>
+          <a:bodyPr/>
+          <a:p/>
+        </p:txBody>
       </p:sp>
       <p:pic>
         <p:nvPicPr>
@@ -8970,6 +9134,10 @@
           </a:solidFill>
           <a:ln/>
         </p:spPr>
+        <p:txBody>
+          <a:bodyPr/>
+          <a:p/>
+        </p:txBody>
       </p:sp>
       <p:sp>
         <p:nvSpPr>
@@ -9004,7 +9172,7 @@
                 <a:ea typeface="Cambria" pitchFamily="34" charset="-122"/>
                 <a:cs typeface="Cambria" pitchFamily="34" charset="-120"/>
               </a:rPr>
-              <a:t>04</a:t>
+              <a:t>19</a:t>
             </a:r>
             <a:endParaRPr lang="en-US" sz="2000" dirty="0"/>
           </a:p>
@@ -9029,6 +9197,10 @@
           </a:solidFill>
           <a:ln/>
         </p:spPr>
+        <p:txBody>
+          <a:bodyPr/>
+          <a:p/>
+        </p:txBody>
       </p:sp>
       <p:pic>
         <p:nvPicPr>
@@ -9165,7 +9337,7 @@
                 <a:ea typeface="Calibri" pitchFamily="34" charset="-122"/>
                 <a:cs typeface="Calibri" pitchFamily="34" charset="-120"/>
               </a:rPr>
-              <a:t>17</a:t>
+              <a:t>19</a:t>
             </a:r>
             <a:endParaRPr lang="en-US" sz="1000" dirty="0"/>
           </a:p>
@@ -9300,6 +9472,10 @@
           </a:solidFill>
           <a:ln/>
         </p:spPr>
+        <p:txBody>
+          <a:bodyPr/>
+          <a:p/>
+        </p:txBody>
       </p:sp>
       <p:pic>
         <p:nvPicPr>
@@ -9431,6 +9607,10 @@
           </a:solidFill>
           <a:ln/>
         </p:spPr>
+        <p:txBody>
+          <a:bodyPr/>
+          <a:p/>
+        </p:txBody>
       </p:sp>
       <p:sp>
         <p:nvSpPr>
@@ -9816,7 +9996,7 @@
                 <a:ea typeface="Calibri" pitchFamily="34" charset="-122"/>
                 <a:cs typeface="Calibri" pitchFamily="34" charset="-120"/>
               </a:rPr>
-              <a:t>18</a:t>
+              <a:t>20</a:t>
             </a:r>
             <a:endParaRPr lang="en-US" sz="1000" dirty="0"/>
           </a:p>
@@ -9958,6 +10138,10 @@
             <a:prstDash val="solid"/>
           </a:ln>
         </p:spPr>
+        <p:txBody>
+          <a:bodyPr/>
+          <a:p/>
+        </p:txBody>
       </p:sp>
       <p:sp>
         <p:nvSpPr>
@@ -10119,6 +10303,10 @@
           </a:solidFill>
           <a:ln/>
         </p:spPr>
+        <p:txBody>
+          <a:bodyPr/>
+          <a:p/>
+        </p:txBody>
       </p:sp>
       <p:pic>
         <p:nvPicPr>
@@ -10163,6 +10351,10 @@
           </a:solidFill>
           <a:ln/>
         </p:spPr>
+        <p:txBody>
+          <a:bodyPr/>
+          <a:p/>
+        </p:txBody>
       </p:sp>
       <p:pic>
         <p:nvPicPr>
@@ -10260,7 +10452,7 @@
                 <a:ea typeface="Calibri" pitchFamily="34" charset="-122"/>
                 <a:cs typeface="Calibri" pitchFamily="34" charset="-120"/>
               </a:rPr>
-              <a:t>19</a:t>
+              <a:t>22</a:t>
             </a:r>
             <a:endParaRPr lang="en-US" sz="1000" dirty="0"/>
           </a:p>
@@ -10443,6 +10635,10 @@
             </a:outerShdw>
           </a:effectLst>
         </p:spPr>
+        <p:txBody>
+          <a:bodyPr/>
+          <a:p/>
+        </p:txBody>
       </p:sp>
       <p:sp>
         <p:nvSpPr>
@@ -10463,6 +10659,10 @@
           </a:solidFill>
           <a:ln/>
         </p:spPr>
+        <p:txBody>
+          <a:bodyPr/>
+          <a:p/>
+        </p:txBody>
       </p:sp>
       <p:pic>
         <p:nvPicPr>
@@ -10640,6 +10840,10 @@
             </a:outerShdw>
           </a:effectLst>
         </p:spPr>
+        <p:txBody>
+          <a:bodyPr/>
+          <a:p/>
+        </p:txBody>
       </p:sp>
       <p:sp>
         <p:nvSpPr>
@@ -10660,6 +10864,10 @@
           </a:solidFill>
           <a:ln/>
         </p:spPr>
+        <p:txBody>
+          <a:bodyPr/>
+          <a:p/>
+        </p:txBody>
       </p:sp>
       <p:pic>
         <p:nvPicPr>
@@ -11025,6 +11233,10 @@
             </a:outerShdw>
           </a:effectLst>
         </p:spPr>
+        <p:txBody>
+          <a:bodyPr/>
+          <a:p/>
+        </p:txBody>
       </p:sp>
       <p:sp>
         <p:nvSpPr>
@@ -11045,6 +11257,10 @@
           </a:solidFill>
           <a:ln/>
         </p:spPr>
+        <p:txBody>
+          <a:bodyPr/>
+          <a:p/>
+        </p:txBody>
       </p:sp>
       <p:pic>
         <p:nvPicPr>
@@ -11222,6 +11438,10 @@
             </a:outerShdw>
           </a:effectLst>
         </p:spPr>
+        <p:txBody>
+          <a:bodyPr/>
+          <a:p/>
+        </p:txBody>
       </p:sp>
       <p:sp>
         <p:nvSpPr>
@@ -11242,6 +11462,10 @@
           </a:solidFill>
           <a:ln/>
         </p:spPr>
+        <p:txBody>
+          <a:bodyPr/>
+          <a:p/>
+        </p:txBody>
       </p:sp>
       <p:pic>
         <p:nvPicPr>
@@ -11424,7 +11648,7 @@
                 <a:ea typeface="Calibri" pitchFamily="34" charset="-122"/>
                 <a:cs typeface="Calibri" pitchFamily="34" charset="-120"/>
               </a:rPr>
-              <a:t>20</a:t>
+              <a:t>23</a:t>
             </a:r>
             <a:endParaRPr lang="en-US" sz="1000" dirty="0"/>
           </a:p>
@@ -11559,6 +11783,10 @@
           </a:solidFill>
           <a:ln/>
         </p:spPr>
+        <p:txBody>
+          <a:bodyPr/>
+          <a:p/>
+        </p:txBody>
       </p:sp>
       <p:pic>
         <p:nvPicPr>
@@ -11642,6 +11870,10 @@
           </a:solidFill>
           <a:ln/>
         </p:spPr>
+        <p:txBody>
+          <a:bodyPr/>
+          <a:p/>
+        </p:txBody>
       </p:sp>
       <p:pic>
         <p:nvPicPr>
@@ -11725,6 +11957,10 @@
           </a:solidFill>
           <a:ln/>
         </p:spPr>
+        <p:txBody>
+          <a:bodyPr/>
+          <a:p/>
+        </p:txBody>
       </p:sp>
       <p:pic>
         <p:nvPicPr>
@@ -11808,6 +12044,10 @@
           </a:solidFill>
           <a:ln/>
         </p:spPr>
+        <p:txBody>
+          <a:bodyPr/>
+          <a:p/>
+        </p:txBody>
       </p:sp>
       <p:pic>
         <p:nvPicPr>
@@ -11905,7 +12145,7 @@
                 <a:ea typeface="Calibri" pitchFamily="34" charset="-122"/>
                 <a:cs typeface="Calibri" pitchFamily="34" charset="-120"/>
               </a:rPr>
-              <a:t>21</a:t>
+              <a:t>25</a:t>
             </a:r>
             <a:endParaRPr lang="en-US" sz="1000" dirty="0"/>
           </a:p>
@@ -11964,6 +12204,10 @@
           </a:solidFill>
           <a:ln/>
         </p:spPr>
+        <p:txBody>
+          <a:bodyPr/>
+          <a:p/>
+        </p:txBody>
       </p:sp>
       <p:sp>
         <p:nvSpPr>
@@ -11984,6 +12228,10 @@
           </a:solidFill>
           <a:ln/>
         </p:spPr>
+        <p:txBody>
+          <a:bodyPr/>
+          <a:p/>
+        </p:txBody>
       </p:sp>
       <p:pic>
         <p:nvPicPr>
@@ -12147,6 +12395,10 @@
           </a:solidFill>
           <a:ln/>
         </p:spPr>
+        <p:txBody>
+          <a:bodyPr/>
+          <a:p/>
+        </p:txBody>
       </p:sp>
       <p:sp>
         <p:nvSpPr>
@@ -12325,6 +12577,10 @@
             </a:outerShdw>
           </a:effectLst>
         </p:spPr>
+        <p:txBody>
+          <a:bodyPr/>
+          <a:p/>
+        </p:txBody>
       </p:sp>
       <p:sp>
         <p:nvSpPr>
@@ -12345,6 +12601,10 @@
           </a:solidFill>
           <a:ln/>
         </p:spPr>
+        <p:txBody>
+          <a:bodyPr/>
+          <a:p/>
+        </p:txBody>
       </p:sp>
       <p:pic>
         <p:nvPicPr>
@@ -12524,6 +12784,10 @@
             </a:outerShdw>
           </a:effectLst>
         </p:spPr>
+        <p:txBody>
+          <a:bodyPr/>
+          <a:p/>
+        </p:txBody>
       </p:sp>
       <p:sp>
         <p:nvSpPr>
@@ -12544,6 +12808,10 @@
           </a:solidFill>
           <a:ln/>
         </p:spPr>
+        <p:txBody>
+          <a:bodyPr/>
+          <a:p/>
+        </p:txBody>
       </p:sp>
       <p:pic>
         <p:nvPicPr>
@@ -12767,9 +13035,870 @@
                 <a:ea typeface="Calibri" pitchFamily="34" charset="-122"/>
                 <a:cs typeface="Calibri" pitchFamily="34" charset="-120"/>
               </a:rPr>
-              <a:t>22</a:t>
+              <a:t>27</a:t>
             </a:r>
             <a:endParaRPr lang="en-US" sz="1000" dirty="0"/>
+          </a:p>
+        </p:txBody>
+      </p:sp>
+    </p:spTree>
+  </p:cSld>
+  <p:clrMapOvr>
+    <a:masterClrMapping/>
+  </p:clrMapOvr>
+</p:sld>
+</file>
+
+<file path=ppt/slides/slide24.xml><?xml version="1.0" encoding="utf-8"?>
+<p:sld xmlns:a="http://schemas.openxmlformats.org/drawingml/2006/main" xmlns:p="http://schemas.openxmlformats.org/presentationml/2006/main" xmlns:r="http://schemas.openxmlformats.org/officeDocument/2006/relationships">
+  <p:cSld>
+    <p:bg>
+      <p:bgPr>
+        <a:solidFill>
+          <a:srgbClr val="F4F7F9"/>
+        </a:solidFill>
+        <a:effectLst/>
+      </p:bgPr>
+    </p:bg>
+    <p:spTree>
+      <p:nvGrpSpPr>
+        <p:cNvPr id="1" name=""/>
+        <p:cNvGrpSpPr/>
+        <p:nvPr/>
+      </p:nvGrpSpPr>
+      <p:grpSpPr/>
+      <p:sp>
+        <p:nvSpPr>
+          <p:cNvPr id="2" name="TextBox 1"/>
+          <p:cNvSpPr txBox="1"/>
+          <p:nvPr/>
+        </p:nvSpPr>
+        <p:spPr>
+          <a:xfrm>
+            <a:off x="548640" y="411480"/>
+            <a:ext cx="10515600" cy="320040"/>
+          </a:xfrm>
+          <a:prstGeom prst="rect">
+            <a:avLst/>
+          </a:prstGeom>
+          <a:noFill/>
+        </p:spPr>
+        <p:txBody>
+          <a:bodyPr wrap="square">
+            <a:spAutoFit/>
+          </a:bodyPr>
+          <a:lstStyle/>
+          <a:p>
+            <a:pPr algn="l"/>
+            <a:r>
+              <a:rPr sz="1300" b="1" i="0">
+                <a:solidFill>
+                  <a:srgbClr val="F2A541"/>
+                </a:solidFill>
+                <a:latin typeface="Calibri"/>
+              </a:rPr>
+              <a:t>SOTA EL CAPÓ</a:t>
+            </a:r>
+          </a:p>
+        </p:txBody>
+      </p:sp>
+      <p:sp>
+        <p:nvSpPr>
+          <p:cNvPr id="3" name="TextBox 2"/>
+          <p:cNvSpPr txBox="1"/>
+          <p:nvPr/>
+        </p:nvSpPr>
+        <p:spPr>
+          <a:xfrm>
+            <a:off x="548640" y="685800"/>
+            <a:ext cx="10972800" cy="822960"/>
+          </a:xfrm>
+          <a:prstGeom prst="rect">
+            <a:avLst/>
+          </a:prstGeom>
+          <a:noFill/>
+        </p:spPr>
+        <p:txBody>
+          <a:bodyPr wrap="square">
+            <a:spAutoFit/>
+          </a:bodyPr>
+          <a:lstStyle/>
+          <a:p>
+            <a:pPr algn="l"/>
+            <a:r>
+              <a:rPr sz="2800" b="1" i="0">
+                <a:solidFill>
+                  <a:srgbClr val="16242E"/>
+                </a:solidFill>
+                <a:latin typeface="Cambria"/>
+              </a:rPr>
+              <a:t>El triangle del foc</a:t>
+            </a:r>
+          </a:p>
+        </p:txBody>
+      </p:sp>
+      <p:sp>
+        <p:nvSpPr>
+          <p:cNvPr id="4" name="TextBox 3"/>
+          <p:cNvSpPr txBox="1"/>
+          <p:nvPr/>
+        </p:nvSpPr>
+        <p:spPr>
+          <a:xfrm>
+            <a:off x="548640" y="1417320"/>
+            <a:ext cx="10789920" cy="548640"/>
+          </a:xfrm>
+          <a:prstGeom prst="rect">
+            <a:avLst/>
+          </a:prstGeom>
+          <a:noFill/>
+        </p:spPr>
+        <p:txBody>
+          <a:bodyPr wrap="square">
+            <a:spAutoFit/>
+          </a:bodyPr>
+          <a:lstStyle/>
+          <a:p>
+            <a:pPr algn="l"/>
+            <a:r>
+              <a:rPr sz="1300" b="0" i="0">
+                <a:solidFill>
+                  <a:srgbClr val="5B6B77"/>
+                </a:solidFill>
+                <a:latin typeface="Calibri"/>
+              </a:rPr>
+              <a:t>Calen els tres elements alhora perquè hi hagi foc: n'hi ha prou d'eliminar-ne un.</a:t>
+            </a:r>
+          </a:p>
+        </p:txBody>
+      </p:sp>
+      <p:pic>
+        <p:nvPicPr>
+          <p:cNvPr id="5" name="Picture 4" descr="triangle_foc.png"/>
+          <p:cNvPicPr>
+            <a:picLocks noChangeAspect="1"/>
+          </p:cNvPicPr>
+          <p:nvPr/>
+        </p:nvPicPr>
+        <p:blipFill>
+          <a:blip r:embed="rId2"/>
+          <a:stretch>
+            <a:fillRect/>
+          </a:stretch>
+        </p:blipFill>
+        <p:spPr>
+          <a:xfrm>
+            <a:off x="3507392" y="1920240"/>
+            <a:ext cx="5176910" cy="4206240"/>
+          </a:xfrm>
+          <a:prstGeom prst="rect">
+            <a:avLst/>
+          </a:prstGeom>
+        </p:spPr>
+      </p:pic>
+      <p:sp>
+        <p:nvSpPr>
+          <p:cNvPr id="6" name="TextBox 5"/>
+          <p:cNvSpPr txBox="1"/>
+          <p:nvPr/>
+        </p:nvSpPr>
+        <p:spPr>
+          <a:xfrm>
+            <a:off x="548640" y="6263640"/>
+            <a:ext cx="11064240" cy="457200"/>
+          </a:xfrm>
+          <a:prstGeom prst="rect">
+            <a:avLst/>
+          </a:prstGeom>
+          <a:noFill/>
+        </p:spPr>
+        <p:txBody>
+          <a:bodyPr wrap="square">
+            <a:spAutoFit/>
+          </a:bodyPr>
+          <a:lstStyle/>
+          <a:p>
+            <a:pPr algn="ctr"/>
+            <a:r>
+              <a:rPr sz="1200" b="0" i="1">
+                <a:solidFill>
+                  <a:srgbClr val="5B6B77"/>
+                </a:solidFill>
+                <a:latin typeface="Calibri"/>
+              </a:rPr>
+              <a:t>El triangle del foc: n'hi ha prou d'eliminar un dels tres elements perquè s'apagui.</a:t>
+            </a:r>
+          </a:p>
+        </p:txBody>
+      </p:sp>
+      <p:sp>
+        <p:nvSpPr>
+          <p:cNvPr id="7" name="TextBox 6"/>
+          <p:cNvSpPr txBox="1"/>
+          <p:nvPr/>
+        </p:nvSpPr>
+        <p:spPr>
+          <a:xfrm>
+            <a:off x="11548872" y="6446520"/>
+            <a:ext cx="365760" cy="274320"/>
+          </a:xfrm>
+          <a:prstGeom prst="rect">
+            <a:avLst/>
+          </a:prstGeom>
+          <a:noFill/>
+        </p:spPr>
+        <p:txBody>
+          <a:bodyPr wrap="none">
+            <a:spAutoFit/>
+          </a:bodyPr>
+          <a:lstStyle/>
+          <a:p>
+            <a:pPr algn="r"/>
+            <a:r>
+              <a:rPr sz="1000">
+                <a:solidFill>
+                  <a:srgbClr val="5B6B77"/>
+                </a:solidFill>
+              </a:rPr>
+              <a:t>16</a:t>
+            </a:r>
+          </a:p>
+        </p:txBody>
+      </p:sp>
+    </p:spTree>
+  </p:cSld>
+  <p:clrMapOvr>
+    <a:masterClrMapping/>
+  </p:clrMapOvr>
+</p:sld>
+</file>
+
+<file path=ppt/slides/slide25.xml><?xml version="1.0" encoding="utf-8"?>
+<p:sld xmlns:a="http://schemas.openxmlformats.org/drawingml/2006/main" xmlns:p="http://schemas.openxmlformats.org/presentationml/2006/main" xmlns:r="http://schemas.openxmlformats.org/officeDocument/2006/relationships">
+  <p:cSld>
+    <p:bg>
+      <p:bgPr>
+        <a:solidFill>
+          <a:srgbClr val="F4F7F9"/>
+        </a:solidFill>
+        <a:effectLst/>
+      </p:bgPr>
+    </p:bg>
+    <p:spTree>
+      <p:nvGrpSpPr>
+        <p:cNvPr id="1" name=""/>
+        <p:cNvGrpSpPr/>
+        <p:nvPr/>
+      </p:nvGrpSpPr>
+      <p:grpSpPr/>
+      <p:sp>
+        <p:nvSpPr>
+          <p:cNvPr id="2" name="TextBox 1"/>
+          <p:cNvSpPr txBox="1"/>
+          <p:nvPr/>
+        </p:nvSpPr>
+        <p:spPr>
+          <a:xfrm>
+            <a:off x="548640" y="411480"/>
+            <a:ext cx="10515600" cy="320040"/>
+          </a:xfrm>
+          <a:prstGeom prst="rect">
+            <a:avLst/>
+          </a:prstGeom>
+          <a:noFill/>
+        </p:spPr>
+        <p:txBody>
+          <a:bodyPr wrap="square">
+            <a:spAutoFit/>
+          </a:bodyPr>
+          <a:lstStyle/>
+          <a:p>
+            <a:pPr algn="l"/>
+            <a:r>
+              <a:rPr sz="1300" b="1" i="0">
+                <a:solidFill>
+                  <a:srgbClr val="F2A541"/>
+                </a:solidFill>
+                <a:latin typeface="Calibri"/>
+              </a:rPr>
+              <a:t>UN EXEMPLE REAL</a:t>
+            </a:r>
+          </a:p>
+        </p:txBody>
+      </p:sp>
+      <p:sp>
+        <p:nvSpPr>
+          <p:cNvPr id="3" name="TextBox 2"/>
+          <p:cNvSpPr txBox="1"/>
+          <p:nvPr/>
+        </p:nvSpPr>
+        <p:spPr>
+          <a:xfrm>
+            <a:off x="548640" y="685800"/>
+            <a:ext cx="10972800" cy="822960"/>
+          </a:xfrm>
+          <a:prstGeom prst="rect">
+            <a:avLst/>
+          </a:prstGeom>
+          <a:noFill/>
+        </p:spPr>
+        <p:txBody>
+          <a:bodyPr wrap="square">
+            <a:spAutoFit/>
+          </a:bodyPr>
+          <a:lstStyle/>
+          <a:p>
+            <a:pPr algn="l"/>
+            <a:r>
+              <a:rPr sz="2800" b="1" i="0">
+                <a:solidFill>
+                  <a:srgbClr val="16242E"/>
+                </a:solidFill>
+                <a:latin typeface="Cambria"/>
+              </a:rPr>
+              <a:t>Extintor de pols ABC</a:t>
+            </a:r>
+          </a:p>
+        </p:txBody>
+      </p:sp>
+      <p:sp>
+        <p:nvSpPr>
+          <p:cNvPr id="4" name="TextBox 3"/>
+          <p:cNvSpPr txBox="1"/>
+          <p:nvPr/>
+        </p:nvSpPr>
+        <p:spPr>
+          <a:xfrm>
+            <a:off x="548640" y="1417320"/>
+            <a:ext cx="10789920" cy="548640"/>
+          </a:xfrm>
+          <a:prstGeom prst="rect">
+            <a:avLst/>
+          </a:prstGeom>
+          <a:noFill/>
+        </p:spPr>
+        <p:txBody>
+          <a:bodyPr wrap="square">
+            <a:spAutoFit/>
+          </a:bodyPr>
+          <a:lstStyle/>
+          <a:p>
+            <a:pPr algn="l"/>
+            <a:r>
+              <a:rPr sz="1300" b="0" i="0">
+                <a:solidFill>
+                  <a:srgbClr val="5B6B77"/>
+                </a:solidFill>
+                <a:latin typeface="Calibri"/>
+              </a:rPr>
+              <a:t>Els extintors són una de les mesures bàsiques de prevenció d'incendis.</a:t>
+            </a:r>
+          </a:p>
+        </p:txBody>
+      </p:sp>
+      <p:pic>
+        <p:nvPicPr>
+          <p:cNvPr id="5" name="Picture 4" descr="foto_extintor.png"/>
+          <p:cNvPicPr>
+            <a:picLocks noChangeAspect="1"/>
+          </p:cNvPicPr>
+          <p:nvPr/>
+        </p:nvPicPr>
+        <p:blipFill>
+          <a:blip r:embed="rId2"/>
+          <a:stretch>
+            <a:fillRect/>
+          </a:stretch>
+        </p:blipFill>
+        <p:spPr>
+          <a:xfrm>
+            <a:off x="5037756" y="1920240"/>
+            <a:ext cx="2116182" cy="4206240"/>
+          </a:xfrm>
+          <a:prstGeom prst="rect">
+            <a:avLst/>
+          </a:prstGeom>
+        </p:spPr>
+      </p:pic>
+      <p:sp>
+        <p:nvSpPr>
+          <p:cNvPr id="6" name="TextBox 5"/>
+          <p:cNvSpPr txBox="1"/>
+          <p:nvPr/>
+        </p:nvSpPr>
+        <p:spPr>
+          <a:xfrm>
+            <a:off x="548640" y="6263640"/>
+            <a:ext cx="11064240" cy="457200"/>
+          </a:xfrm>
+          <a:prstGeom prst="rect">
+            <a:avLst/>
+          </a:prstGeom>
+          <a:noFill/>
+        </p:spPr>
+        <p:txBody>
+          <a:bodyPr wrap="square">
+            <a:spAutoFit/>
+          </a:bodyPr>
+          <a:lstStyle/>
+          <a:p>
+            <a:pPr algn="ctr"/>
+            <a:r>
+              <a:rPr sz="1200" b="0" i="1">
+                <a:solidFill>
+                  <a:srgbClr val="5B6B77"/>
+                </a:solidFill>
+                <a:latin typeface="Calibri"/>
+              </a:rPr>
+              <a:t>Cal que passin revisions periòdiques perquè siguin fiables quan calgui.</a:t>
+            </a:r>
+          </a:p>
+        </p:txBody>
+      </p:sp>
+      <p:sp>
+        <p:nvSpPr>
+          <p:cNvPr id="7" name="TextBox 6"/>
+          <p:cNvSpPr txBox="1"/>
+          <p:nvPr/>
+        </p:nvSpPr>
+        <p:spPr>
+          <a:xfrm>
+            <a:off x="11548872" y="6446520"/>
+            <a:ext cx="365760" cy="274320"/>
+          </a:xfrm>
+          <a:prstGeom prst="rect">
+            <a:avLst/>
+          </a:prstGeom>
+          <a:noFill/>
+        </p:spPr>
+        <p:txBody>
+          <a:bodyPr wrap="none">
+            <a:spAutoFit/>
+          </a:bodyPr>
+          <a:lstStyle/>
+          <a:p>
+            <a:pPr algn="r"/>
+            <a:r>
+              <a:rPr sz="1000">
+                <a:solidFill>
+                  <a:srgbClr val="5B6B77"/>
+                </a:solidFill>
+              </a:rPr>
+              <a:t>18</a:t>
+            </a:r>
+          </a:p>
+        </p:txBody>
+      </p:sp>
+    </p:spTree>
+  </p:cSld>
+  <p:clrMapOvr>
+    <a:masterClrMapping/>
+  </p:clrMapOvr>
+</p:sld>
+</file>
+
+<file path=ppt/slides/slide26.xml><?xml version="1.0" encoding="utf-8"?>
+<p:sld xmlns:a="http://schemas.openxmlformats.org/drawingml/2006/main" xmlns:p="http://schemas.openxmlformats.org/presentationml/2006/main" xmlns:r="http://schemas.openxmlformats.org/officeDocument/2006/relationships">
+  <p:cSld>
+    <p:bg>
+      <p:bgPr>
+        <a:solidFill>
+          <a:srgbClr val="F4F7F9"/>
+        </a:solidFill>
+        <a:effectLst/>
+      </p:bgPr>
+    </p:bg>
+    <p:spTree>
+      <p:nvGrpSpPr>
+        <p:cNvPr id="1" name=""/>
+        <p:cNvGrpSpPr/>
+        <p:nvPr/>
+      </p:nvGrpSpPr>
+      <p:grpSpPr/>
+      <p:sp>
+        <p:nvSpPr>
+          <p:cNvPr id="2" name="TextBox 1"/>
+          <p:cNvSpPr txBox="1"/>
+          <p:nvPr/>
+        </p:nvSpPr>
+        <p:spPr>
+          <a:xfrm>
+            <a:off x="548640" y="411480"/>
+            <a:ext cx="10515600" cy="320040"/>
+          </a:xfrm>
+          <a:prstGeom prst="rect">
+            <a:avLst/>
+          </a:prstGeom>
+          <a:noFill/>
+        </p:spPr>
+        <p:txBody>
+          <a:bodyPr wrap="square">
+            <a:spAutoFit/>
+          </a:bodyPr>
+          <a:lstStyle/>
+          <a:p>
+            <a:pPr algn="l"/>
+            <a:r>
+              <a:rPr sz="1300" b="1" i="0">
+                <a:solidFill>
+                  <a:srgbClr val="F2A541"/>
+                </a:solidFill>
+                <a:latin typeface="Calibri"/>
+              </a:rPr>
+              <a:t>UN EXEMPLE REAL</a:t>
+            </a:r>
+          </a:p>
+        </p:txBody>
+      </p:sp>
+      <p:sp>
+        <p:nvSpPr>
+          <p:cNvPr id="3" name="TextBox 2"/>
+          <p:cNvSpPr txBox="1"/>
+          <p:nvPr/>
+        </p:nvSpPr>
+        <p:spPr>
+          <a:xfrm>
+            <a:off x="548640" y="685800"/>
+            <a:ext cx="10972800" cy="822960"/>
+          </a:xfrm>
+          <a:prstGeom prst="rect">
+            <a:avLst/>
+          </a:prstGeom>
+          <a:noFill/>
+        </p:spPr>
+        <p:txBody>
+          <a:bodyPr wrap="square">
+            <a:spAutoFit/>
+          </a:bodyPr>
+          <a:lstStyle/>
+          <a:p>
+            <a:pPr algn="l"/>
+            <a:r>
+              <a:rPr sz="2800" b="1" i="0">
+                <a:solidFill>
+                  <a:srgbClr val="16242E"/>
+                </a:solidFill>
+                <a:latin typeface="Cambria"/>
+              </a:rPr>
+              <a:t>Tanca perimetral</a:t>
+            </a:r>
+          </a:p>
+        </p:txBody>
+      </p:sp>
+      <p:sp>
+        <p:nvSpPr>
+          <p:cNvPr id="4" name="TextBox 3"/>
+          <p:cNvSpPr txBox="1"/>
+          <p:nvPr/>
+        </p:nvSpPr>
+        <p:spPr>
+          <a:xfrm>
+            <a:off x="548640" y="1417320"/>
+            <a:ext cx="10789920" cy="548640"/>
+          </a:xfrm>
+          <a:prstGeom prst="rect">
+            <a:avLst/>
+          </a:prstGeom>
+          <a:noFill/>
+        </p:spPr>
+        <p:txBody>
+          <a:bodyPr wrap="square">
+            <a:spAutoFit/>
+          </a:bodyPr>
+          <a:lstStyle/>
+          <a:p>
+            <a:pPr algn="l"/>
+            <a:r>
+              <a:rPr sz="1300" b="0" i="0">
+                <a:solidFill>
+                  <a:srgbClr val="5B6B77"/>
+                </a:solidFill>
+                <a:latin typeface="Calibri"/>
+              </a:rPr>
+              <a:t>L'alçada d'una tanca canvia molt el seu efecte dissuasiu.</a:t>
+            </a:r>
+          </a:p>
+        </p:txBody>
+      </p:sp>
+      <p:pic>
+        <p:nvPicPr>
+          <p:cNvPr id="5" name="Picture 4" descr="foto_tanca_perimetral.png"/>
+          <p:cNvPicPr>
+            <a:picLocks noChangeAspect="1"/>
+          </p:cNvPicPr>
+          <p:nvPr/>
+        </p:nvPicPr>
+        <p:blipFill>
+          <a:blip r:embed="rId2"/>
+          <a:stretch>
+            <a:fillRect/>
+          </a:stretch>
+        </p:blipFill>
+        <p:spPr>
+          <a:xfrm>
+            <a:off x="3157952" y="1920240"/>
+            <a:ext cx="5875790" cy="3931920"/>
+          </a:xfrm>
+          <a:prstGeom prst="rect">
+            <a:avLst/>
+          </a:prstGeom>
+        </p:spPr>
+      </p:pic>
+      <p:sp>
+        <p:nvSpPr>
+          <p:cNvPr id="6" name="TextBox 5"/>
+          <p:cNvSpPr txBox="1"/>
+          <p:nvPr/>
+        </p:nvSpPr>
+        <p:spPr>
+          <a:xfrm>
+            <a:off x="548640" y="5989320"/>
+            <a:ext cx="11064240" cy="457200"/>
+          </a:xfrm>
+          <a:prstGeom prst="rect">
+            <a:avLst/>
+          </a:prstGeom>
+          <a:noFill/>
+        </p:spPr>
+        <p:txBody>
+          <a:bodyPr wrap="square">
+            <a:spAutoFit/>
+          </a:bodyPr>
+          <a:lstStyle/>
+          <a:p>
+            <a:pPr algn="ctr"/>
+            <a:r>
+              <a:rPr sz="1200" b="0" i="1">
+                <a:solidFill>
+                  <a:srgbClr val="5B6B77"/>
+                </a:solidFill>
+                <a:latin typeface="Calibri"/>
+              </a:rPr>
+              <a:t>Les tanques han de tenir una alçada determinada perquè siguin eficaces com a mesura dissuasiva contra intrusos.</a:t>
+            </a:r>
+          </a:p>
+        </p:txBody>
+      </p:sp>
+      <p:sp>
+        <p:nvSpPr>
+          <p:cNvPr id="7" name="TextBox 6"/>
+          <p:cNvSpPr txBox="1"/>
+          <p:nvPr/>
+        </p:nvSpPr>
+        <p:spPr>
+          <a:xfrm>
+            <a:off x="11548872" y="6446520"/>
+            <a:ext cx="365760" cy="274320"/>
+          </a:xfrm>
+          <a:prstGeom prst="rect">
+            <a:avLst/>
+          </a:prstGeom>
+          <a:noFill/>
+        </p:spPr>
+        <p:txBody>
+          <a:bodyPr wrap="none">
+            <a:spAutoFit/>
+          </a:bodyPr>
+          <a:lstStyle/>
+          <a:p>
+            <a:pPr algn="r"/>
+            <a:r>
+              <a:rPr sz="1000">
+                <a:solidFill>
+                  <a:srgbClr val="5B6B77"/>
+                </a:solidFill>
+              </a:rPr>
+              <a:t>21</a:t>
+            </a:r>
+          </a:p>
+        </p:txBody>
+      </p:sp>
+    </p:spTree>
+  </p:cSld>
+  <p:clrMapOvr>
+    <a:masterClrMapping/>
+  </p:clrMapOvr>
+</p:sld>
+</file>
+
+<file path=ppt/slides/slide27.xml><?xml version="1.0" encoding="utf-8"?>
+<p:sld xmlns:a="http://schemas.openxmlformats.org/drawingml/2006/main" xmlns:p="http://schemas.openxmlformats.org/presentationml/2006/main" xmlns:r="http://schemas.openxmlformats.org/officeDocument/2006/relationships">
+  <p:cSld>
+    <p:bg>
+      <p:bgPr>
+        <a:solidFill>
+          <a:srgbClr val="F4F7F9"/>
+        </a:solidFill>
+        <a:effectLst/>
+      </p:bgPr>
+    </p:bg>
+    <p:spTree>
+      <p:nvGrpSpPr>
+        <p:cNvPr id="1" name=""/>
+        <p:cNvGrpSpPr/>
+        <p:nvPr/>
+      </p:nvGrpSpPr>
+      <p:grpSpPr/>
+      <p:sp>
+        <p:nvSpPr>
+          <p:cNvPr id="2" name="TextBox 1"/>
+          <p:cNvSpPr txBox="1"/>
+          <p:nvPr/>
+        </p:nvSpPr>
+        <p:spPr>
+          <a:xfrm>
+            <a:off x="548640" y="411480"/>
+            <a:ext cx="10515600" cy="320040"/>
+          </a:xfrm>
+          <a:prstGeom prst="rect">
+            <a:avLst/>
+          </a:prstGeom>
+          <a:noFill/>
+        </p:spPr>
+        <p:txBody>
+          <a:bodyPr wrap="square">
+            <a:spAutoFit/>
+          </a:bodyPr>
+          <a:lstStyle/>
+          <a:p>
+            <a:pPr algn="l"/>
+            <a:r>
+              <a:rPr sz="1300" b="1" i="0">
+                <a:solidFill>
+                  <a:srgbClr val="F2A541"/>
+                </a:solidFill>
+                <a:latin typeface="Calibri"/>
+              </a:rPr>
+              <a:t>HO SABIES?</a:t>
+            </a:r>
+          </a:p>
+        </p:txBody>
+      </p:sp>
+      <p:sp>
+        <p:nvSpPr>
+          <p:cNvPr id="3" name="TextBox 2"/>
+          <p:cNvSpPr txBox="1"/>
+          <p:nvPr/>
+        </p:nvSpPr>
+        <p:spPr>
+          <a:xfrm>
+            <a:off x="548640" y="685800"/>
+            <a:ext cx="10972800" cy="822960"/>
+          </a:xfrm>
+          <a:prstGeom prst="rect">
+            <a:avLst/>
+          </a:prstGeom>
+          <a:noFill/>
+        </p:spPr>
+        <p:txBody>
+          <a:bodyPr wrap="square">
+            <a:spAutoFit/>
+          </a:bodyPr>
+          <a:lstStyle/>
+          <a:p>
+            <a:pPr algn="l"/>
+            <a:r>
+              <a:rPr sz="2800" b="1" i="0">
+                <a:solidFill>
+                  <a:srgbClr val="16242E"/>
+                </a:solidFill>
+                <a:latin typeface="Cambria"/>
+              </a:rPr>
+              <a:t>El cinema i la detecció d'intrusos</a:t>
+            </a:r>
+          </a:p>
+        </p:txBody>
+      </p:sp>
+      <p:pic>
+        <p:nvPicPr>
+          <p:cNvPr id="4" name="Picture 3" descr="foto_intrus_pellicula.png"/>
+          <p:cNvPicPr>
+            <a:picLocks noChangeAspect="1"/>
+          </p:cNvPicPr>
+          <p:nvPr/>
+        </p:nvPicPr>
+        <p:blipFill>
+          <a:blip r:embed="rId2"/>
+          <a:stretch>
+            <a:fillRect/>
+          </a:stretch>
+        </p:blipFill>
+        <p:spPr>
+          <a:xfrm>
+            <a:off x="3157952" y="1920240"/>
+            <a:ext cx="5875790" cy="3931920"/>
+          </a:xfrm>
+          <a:prstGeom prst="rect">
+            <a:avLst/>
+          </a:prstGeom>
+        </p:spPr>
+      </p:pic>
+      <p:sp>
+        <p:nvSpPr>
+          <p:cNvPr id="5" name="TextBox 4"/>
+          <p:cNvSpPr txBox="1"/>
+          <p:nvPr/>
+        </p:nvSpPr>
+        <p:spPr>
+          <a:xfrm>
+            <a:off x="548640" y="5989320"/>
+            <a:ext cx="11064240" cy="457200"/>
+          </a:xfrm>
+          <a:prstGeom prst="rect">
+            <a:avLst/>
+          </a:prstGeom>
+          <a:noFill/>
+        </p:spPr>
+        <p:txBody>
+          <a:bodyPr wrap="square">
+            <a:spAutoFit/>
+          </a:bodyPr>
+          <a:lstStyle/>
+          <a:p>
+            <a:pPr algn="ctr"/>
+            <a:r>
+              <a:rPr sz="1200" b="0" i="1">
+                <a:solidFill>
+                  <a:srgbClr val="5B6B77"/>
+                </a:solidFill>
+                <a:latin typeface="Calibri"/>
+              </a:rPr>
+              <a:t>Algunes pel·lícules ens mostren com els intrusos intenten burlar els sistemes de detecció d'intrusos.</a:t>
+            </a:r>
+          </a:p>
+        </p:txBody>
+      </p:sp>
+      <p:sp>
+        <p:nvSpPr>
+          <p:cNvPr id="6" name="TextBox 5"/>
+          <p:cNvSpPr txBox="1"/>
+          <p:nvPr/>
+        </p:nvSpPr>
+        <p:spPr>
+          <a:xfrm>
+            <a:off x="11548872" y="6446520"/>
+            <a:ext cx="365760" cy="274320"/>
+          </a:xfrm>
+          <a:prstGeom prst="rect">
+            <a:avLst/>
+          </a:prstGeom>
+          <a:noFill/>
+        </p:spPr>
+        <p:txBody>
+          <a:bodyPr wrap="none">
+            <a:spAutoFit/>
+          </a:bodyPr>
+          <a:lstStyle/>
+          <a:p>
+            <a:pPr algn="r"/>
+            <a:r>
+              <a:rPr sz="1000">
+                <a:solidFill>
+                  <a:srgbClr val="5B6B77"/>
+                </a:solidFill>
+              </a:rPr>
+              <a:t>24</a:t>
+            </a:r>
           </a:p>
         </p:txBody>
       </p:sp>
@@ -12824,6 +13953,10 @@
           </a:solidFill>
           <a:ln/>
         </p:spPr>
+        <p:txBody>
+          <a:bodyPr/>
+          <a:p/>
+        </p:txBody>
       </p:sp>
       <p:sp>
         <p:nvSpPr>
@@ -12929,6 +14062,10 @@
             <a:prstDash val="solid"/>
           </a:ln>
         </p:spPr>
+        <p:txBody>
+          <a:bodyPr/>
+          <a:p/>
+        </p:txBody>
       </p:sp>
       <p:sp>
         <p:nvSpPr>
@@ -12949,6 +14086,10 @@
           </a:solidFill>
           <a:ln/>
         </p:spPr>
+        <p:txBody>
+          <a:bodyPr/>
+          <a:p/>
+        </p:txBody>
       </p:sp>
       <p:pic>
         <p:nvPicPr>
@@ -13073,6 +14214,10 @@
           </a:solidFill>
           <a:ln/>
         </p:spPr>
+        <p:txBody>
+          <a:bodyPr/>
+          <a:p/>
+        </p:txBody>
       </p:sp>
       <p:sp>
         <p:nvSpPr>
@@ -13093,6 +14238,10 @@
           </a:solidFill>
           <a:ln/>
         </p:spPr>
+        <p:txBody>
+          <a:bodyPr/>
+          <a:p/>
+        </p:txBody>
       </p:sp>
       <p:pic>
         <p:nvPicPr>
@@ -13373,6 +14522,10 @@
             </a:outerShdw>
           </a:effectLst>
         </p:spPr>
+        <p:txBody>
+          <a:bodyPr/>
+          <a:p/>
+        </p:txBody>
       </p:sp>
       <p:sp>
         <p:nvSpPr>
@@ -13432,6 +14585,10 @@
           </a:solidFill>
           <a:ln/>
         </p:spPr>
+        <p:txBody>
+          <a:bodyPr/>
+          <a:p/>
+        </p:txBody>
       </p:sp>
       <p:pic>
         <p:nvPicPr>
@@ -13563,6 +14720,10 @@
             </a:outerShdw>
           </a:effectLst>
         </p:spPr>
+        <p:txBody>
+          <a:bodyPr/>
+          <a:p/>
+        </p:txBody>
       </p:sp>
       <p:sp>
         <p:nvSpPr>
@@ -13583,6 +14744,10 @@
           </a:solidFill>
           <a:ln/>
         </p:spPr>
+        <p:txBody>
+          <a:bodyPr/>
+          <a:p/>
+        </p:txBody>
       </p:sp>
       <p:pic>
         <p:nvPicPr>
@@ -13714,6 +14879,10 @@
             </a:outerShdw>
           </a:effectLst>
         </p:spPr>
+        <p:txBody>
+          <a:bodyPr/>
+          <a:p/>
+        </p:txBody>
       </p:sp>
       <p:sp>
         <p:nvSpPr>
@@ -13734,6 +14903,10 @@
           </a:solidFill>
           <a:ln/>
         </p:spPr>
+        <p:txBody>
+          <a:bodyPr/>
+          <a:p/>
+        </p:txBody>
       </p:sp>
       <p:pic>
         <p:nvPicPr>
@@ -14014,6 +15187,10 @@
             </a:outerShdw>
           </a:effectLst>
         </p:spPr>
+        <p:txBody>
+          <a:bodyPr/>
+          <a:p/>
+        </p:txBody>
       </p:sp>
       <p:sp>
         <p:nvSpPr>
@@ -14034,6 +15211,10 @@
           </a:solidFill>
           <a:ln/>
         </p:spPr>
+        <p:txBody>
+          <a:bodyPr/>
+          <a:p/>
+        </p:txBody>
       </p:sp>
       <p:pic>
         <p:nvPicPr>
@@ -14165,6 +15346,10 @@
             </a:outerShdw>
           </a:effectLst>
         </p:spPr>
+        <p:txBody>
+          <a:bodyPr/>
+          <a:p/>
+        </p:txBody>
       </p:sp>
       <p:sp>
         <p:nvSpPr>
@@ -14185,6 +15370,10 @@
           </a:solidFill>
           <a:ln/>
         </p:spPr>
+        <p:txBody>
+          <a:bodyPr/>
+          <a:p/>
+        </p:txBody>
       </p:sp>
       <p:pic>
         <p:nvPicPr>
@@ -14316,6 +15505,10 @@
             </a:outerShdw>
           </a:effectLst>
         </p:spPr>
+        <p:txBody>
+          <a:bodyPr/>
+          <a:p/>
+        </p:txBody>
       </p:sp>
       <p:sp>
         <p:nvSpPr>
@@ -14336,6 +15529,10 @@
           </a:solidFill>
           <a:ln/>
         </p:spPr>
+        <p:txBody>
+          <a:bodyPr/>
+          <a:p/>
+        </p:txBody>
       </p:sp>
       <p:pic>
         <p:nvPicPr>
@@ -14614,6 +15811,10 @@
             <a:prstDash val="solid"/>
           </a:ln>
         </p:spPr>
+        <p:txBody>
+          <a:bodyPr/>
+          <a:p/>
+        </p:txBody>
       </p:sp>
       <p:sp>
         <p:nvSpPr>
@@ -14634,6 +15835,10 @@
           </a:solidFill>
           <a:ln/>
         </p:spPr>
+        <p:txBody>
+          <a:bodyPr/>
+          <a:p/>
+        </p:txBody>
       </p:sp>
       <p:pic>
         <p:nvPicPr>
@@ -14758,6 +15963,10 @@
           </a:solidFill>
           <a:ln/>
         </p:spPr>
+        <p:txBody>
+          <a:bodyPr/>
+          <a:p/>
+        </p:txBody>
       </p:sp>
       <p:sp>
         <p:nvSpPr>
@@ -14778,6 +15987,10 @@
           </a:solidFill>
           <a:ln/>
         </p:spPr>
+        <p:txBody>
+          <a:bodyPr/>
+          <a:p/>
+        </p:txBody>
       </p:sp>
       <p:pic>
         <p:nvPicPr>
@@ -14900,6 +16113,10 @@
           </a:solidFill>
           <a:ln/>
         </p:spPr>
+        <p:txBody>
+          <a:bodyPr/>
+          <a:p/>
+        </p:txBody>
       </p:sp>
       <p:pic>
         <p:nvPicPr>
@@ -15102,6 +16319,10 @@
             </a:outerShdw>
           </a:effectLst>
         </p:spPr>
+        <p:txBody>
+          <a:bodyPr/>
+          <a:p/>
+        </p:txBody>
       </p:sp>
       <p:sp>
         <p:nvSpPr>
@@ -15122,6 +16343,10 @@
           </a:solidFill>
           <a:ln/>
         </p:spPr>
+        <p:txBody>
+          <a:bodyPr/>
+          <a:p/>
+        </p:txBody>
       </p:sp>
       <p:pic>
         <p:nvPicPr>
@@ -15299,6 +16524,10 @@
             </a:outerShdw>
           </a:effectLst>
         </p:spPr>
+        <p:txBody>
+          <a:bodyPr/>
+          <a:p/>
+        </p:txBody>
       </p:sp>
       <p:sp>
         <p:nvSpPr>
@@ -15319,6 +16548,10 @@
           </a:solidFill>
           <a:ln/>
         </p:spPr>
+        <p:txBody>
+          <a:bodyPr/>
+          <a:p/>
+        </p:txBody>
       </p:sp>
       <p:pic>
         <p:nvPicPr>
@@ -15716,6 +16949,10 @@
           </a:solidFill>
           <a:ln/>
         </p:spPr>
+        <p:txBody>
+          <a:bodyPr/>
+          <a:p/>
+        </p:txBody>
       </p:sp>
       <p:sp>
         <p:nvSpPr>
@@ -15736,6 +16973,10 @@
           </a:solidFill>
           <a:ln/>
         </p:spPr>
+        <p:txBody>
+          <a:bodyPr/>
+          <a:p/>
+        </p:txBody>
       </p:sp>
       <p:pic>
         <p:nvPicPr>
@@ -15796,7 +17037,7 @@
                 <a:ea typeface="Cambria" pitchFamily="34" charset="-122"/>
                 <a:cs typeface="Cambria" pitchFamily="34" charset="-120"/>
               </a:rPr>
-              <a:t>1</a:t>
+              <a:t>8</a:t>
             </a:r>
             <a:endParaRPr lang="en-US" sz="1600" dirty="0"/>
           </a:p>
@@ -15886,6 +17127,10 @@
           </a:solidFill>
           <a:ln/>
         </p:spPr>
+        <p:txBody>
+          <a:bodyPr/>
+          <a:p/>
+        </p:txBody>
       </p:sp>
       <p:sp>
         <p:nvSpPr>
@@ -15906,6 +17151,10 @@
           </a:solidFill>
           <a:ln/>
         </p:spPr>
+        <p:txBody>
+          <a:bodyPr/>
+          <a:p/>
+        </p:txBody>
       </p:sp>
       <p:pic>
         <p:nvPicPr>
@@ -15966,7 +17215,7 @@
                 <a:ea typeface="Cambria" pitchFamily="34" charset="-122"/>
                 <a:cs typeface="Cambria" pitchFamily="34" charset="-120"/>
               </a:rPr>
-              <a:t>2</a:t>
+              <a:t>8</a:t>
             </a:r>
             <a:endParaRPr lang="en-US" sz="1600" dirty="0"/>
           </a:p>
@@ -16056,6 +17305,10 @@
           </a:solidFill>
           <a:ln/>
         </p:spPr>
+        <p:txBody>
+          <a:bodyPr/>
+          <a:p/>
+        </p:txBody>
       </p:sp>
       <p:sp>
         <p:nvSpPr>
@@ -16076,6 +17329,10 @@
           </a:solidFill>
           <a:ln/>
         </p:spPr>
+        <p:txBody>
+          <a:bodyPr/>
+          <a:p/>
+        </p:txBody>
       </p:sp>
       <p:pic>
         <p:nvPicPr>
@@ -16136,7 +17393,7 @@
                 <a:ea typeface="Cambria" pitchFamily="34" charset="-122"/>
                 <a:cs typeface="Cambria" pitchFamily="34" charset="-120"/>
               </a:rPr>
-              <a:t>3</a:t>
+              <a:t>8</a:t>
             </a:r>
             <a:endParaRPr lang="en-US" sz="1600" dirty="0"/>
           </a:p>
@@ -16226,6 +17483,10 @@
           </a:solidFill>
           <a:ln/>
         </p:spPr>
+        <p:txBody>
+          <a:bodyPr/>
+          <a:p/>
+        </p:txBody>
       </p:sp>
       <p:sp>
         <p:nvSpPr>
@@ -16246,6 +17507,10 @@
           </a:solidFill>
           <a:ln/>
         </p:spPr>
+        <p:txBody>
+          <a:bodyPr/>
+          <a:p/>
+        </p:txBody>
       </p:sp>
       <p:pic>
         <p:nvPicPr>
@@ -16306,7 +17571,7 @@
                 <a:ea typeface="Cambria" pitchFamily="34" charset="-122"/>
                 <a:cs typeface="Cambria" pitchFamily="34" charset="-120"/>
               </a:rPr>
-              <a:t>4</a:t>
+              <a:t>8</a:t>
             </a:r>
             <a:endParaRPr lang="en-US" sz="1600" dirty="0"/>
           </a:p>
@@ -16567,6 +17832,10 @@
             </a:outerShdw>
           </a:effectLst>
         </p:spPr>
+        <p:txBody>
+          <a:bodyPr/>
+          <a:p/>
+        </p:txBody>
       </p:sp>
       <p:sp>
         <p:nvSpPr>
@@ -16587,6 +17856,10 @@
           </a:solidFill>
           <a:ln/>
         </p:spPr>
+        <p:txBody>
+          <a:bodyPr/>
+          <a:p/>
+        </p:txBody>
       </p:sp>
       <p:pic>
         <p:nvPicPr>
@@ -16718,6 +17991,10 @@
             </a:outerShdw>
           </a:effectLst>
         </p:spPr>
+        <p:txBody>
+          <a:bodyPr/>
+          <a:p/>
+        </p:txBody>
       </p:sp>
       <p:sp>
         <p:nvSpPr>
@@ -16738,6 +18015,10 @@
           </a:solidFill>
           <a:ln/>
         </p:spPr>
+        <p:txBody>
+          <a:bodyPr/>
+          <a:p/>
+        </p:txBody>
       </p:sp>
       <p:pic>
         <p:nvPicPr>
@@ -16862,6 +18143,10 @@
           </a:solidFill>
           <a:ln/>
         </p:spPr>
+        <p:txBody>
+          <a:bodyPr/>
+          <a:p/>
+        </p:txBody>
       </p:sp>
       <p:sp>
         <p:nvSpPr>
@@ -16962,6 +18247,10 @@
           </a:solidFill>
           <a:ln/>
         </p:spPr>
+        <p:txBody>
+          <a:bodyPr/>
+          <a:p/>
+        </p:txBody>
       </p:sp>
       <p:sp>
         <p:nvSpPr>

</xml_diff>